<commit_message>
Update PowerPoint with corrected version
</commit_message>
<xml_diff>
--- a/AmazonTestSuite.pptx
+++ b/AmazonTestSuite.pptx
@@ -272,6 +272,13 @@
           </p:nvPr>
         </p:nvSpPr>
         <p:spPr/>
+        <p:txBody>
+          <a:bodyPr/>
+          <a:lstStyle/>
+          <a:p>
+            <a:endParaRPr lang="en-US"/>
+          </a:p>
+        </p:txBody>
       </p:sp>
       <p:sp>
         <p:nvSpPr>
@@ -356,6 +363,13 @@
           </p:nvPr>
         </p:nvSpPr>
         <p:spPr/>
+        <p:txBody>
+          <a:bodyPr/>
+          <a:lstStyle/>
+          <a:p>
+            <a:endParaRPr lang="en-US"/>
+          </a:p>
+        </p:txBody>
       </p:sp>
       <p:sp>
         <p:nvSpPr>
@@ -440,6 +454,13 @@
           </p:nvPr>
         </p:nvSpPr>
         <p:spPr/>
+        <p:txBody>
+          <a:bodyPr/>
+          <a:lstStyle/>
+          <a:p>
+            <a:endParaRPr lang="en-US"/>
+          </a:p>
+        </p:txBody>
       </p:sp>
       <p:sp>
         <p:nvSpPr>
@@ -524,6 +545,13 @@
           </p:nvPr>
         </p:nvSpPr>
         <p:spPr/>
+        <p:txBody>
+          <a:bodyPr/>
+          <a:lstStyle/>
+          <a:p>
+            <a:endParaRPr lang="en-US"/>
+          </a:p>
+        </p:txBody>
       </p:sp>
       <p:sp>
         <p:nvSpPr>
@@ -608,6 +636,13 @@
           </p:nvPr>
         </p:nvSpPr>
         <p:spPr/>
+        <p:txBody>
+          <a:bodyPr/>
+          <a:lstStyle/>
+          <a:p>
+            <a:endParaRPr lang="en-US"/>
+          </a:p>
+        </p:txBody>
       </p:sp>
       <p:sp>
         <p:nvSpPr>
@@ -692,6 +727,13 @@
           </p:nvPr>
         </p:nvSpPr>
         <p:spPr/>
+        <p:txBody>
+          <a:bodyPr/>
+          <a:lstStyle/>
+          <a:p>
+            <a:endParaRPr lang="en-US"/>
+          </a:p>
+        </p:txBody>
       </p:sp>
       <p:sp>
         <p:nvSpPr>
@@ -776,6 +818,13 @@
           </p:nvPr>
         </p:nvSpPr>
         <p:spPr/>
+        <p:txBody>
+          <a:bodyPr/>
+          <a:lstStyle/>
+          <a:p>
+            <a:endParaRPr lang="en-US"/>
+          </a:p>
+        </p:txBody>
       </p:sp>
       <p:sp>
         <p:nvSpPr>
@@ -860,6 +909,13 @@
           </p:nvPr>
         </p:nvSpPr>
         <p:spPr/>
+        <p:txBody>
+          <a:bodyPr/>
+          <a:lstStyle/>
+          <a:p>
+            <a:endParaRPr lang="en-US"/>
+          </a:p>
+        </p:txBody>
       </p:sp>
       <p:sp>
         <p:nvSpPr>
@@ -1833,7 +1889,7 @@
                 <a:ea typeface="Trebuchet MS" pitchFamily="34" charset="-122"/>
                 <a:cs typeface="Trebuchet MS" pitchFamily="34" charset="-120"/>
               </a:rPr>
-              <a:t>70+ test cases</a:t>
+              <a:t>41 test cases</a:t>
             </a:r>
             <a:endParaRPr lang="en-US" sz="1300" dirty="0"/>
           </a:p>
@@ -1850,7 +1906,7 @@
                 <a:ea typeface="Trebuchet MS" pitchFamily="34" charset="-122"/>
                 <a:cs typeface="Trebuchet MS" pitchFamily="34" charset="-120"/>
               </a:rPr>
-              <a:t>Full cart &amp; checkout flow</a:t>
+              <a:t>Full search and cart flow</a:t>
             </a:r>
             <a:endParaRPr lang="en-US" sz="1300" dirty="0"/>
           </a:p>
@@ -5937,7 +5993,7 @@
                 <a:ea typeface="Georgia" pitchFamily="34" charset="-122"/>
                 <a:cs typeface="Georgia" pitchFamily="34" charset="-120"/>
               </a:rPr>
-              <a:t>Amazon Bot Detection</a:t>
+              <a:t>Dynamic Web Elements</a:t>
             </a:r>
             <a:endParaRPr lang="en-US" sz="1700" dirty="0"/>
           </a:p>
@@ -5976,7 +6032,7 @@
                 <a:ea typeface="Trebuchet MS" pitchFamily="34" charset="-122"/>
                 <a:cs typeface="Trebuchet MS" pitchFamily="34" charset="-120"/>
               </a:rPr>
-              <a:t>Amazon aggressively blocks automated browsers, serving CAPTCHA pages mid-test or blocking navigation entirely. This caused tests to silently pass even when nothing had actually run.</a:t>
+              <a:t>Amazon has a dynamic UI which led to IDs/classes changing, different layouts, or different search results.</a:t>
             </a:r>
             <a:endParaRPr lang="en-US" sz="1200" dirty="0"/>
           </a:p>
@@ -6054,7 +6110,7 @@
                 <a:ea typeface="Trebuchet MS" pitchFamily="34" charset="-122"/>
                 <a:cs typeface="Trebuchet MS" pitchFamily="34" charset="-120"/>
               </a:rPr>
-              <a:t>Built an isRobotCheckPage() helper that detects CAPTCHA pages by inspecting the page source and title. Tests check this flag and skip gracefully rather than producing false passes. We also set up a dedicated Chrome profile with an active Amazon login — making the session appear as a real returning user and significantly reducing bot triggers.</a:t>
+              <a:t>Used flexible locators such as CSS selectors instead of rigid XPaths. Also added helper methods like elementExists() and pageContainsAny() for particularly difficult locators.</a:t>
             </a:r>
             <a:endParaRPr lang="en-US" sz="1150" dirty="0"/>
           </a:p>
@@ -6303,29 +6359,7 @@
                 <a:ea typeface="Trebuchet MS" pitchFamily="34" charset="-122"/>
                 <a:cs typeface="Trebuchet MS" pitchFamily="34" charset="-120"/>
               </a:rPr>
-              <a:t>Switched from isDisplayed() checks to pure DOM presence, </a:t>
-            </a:r>
-            <a:r>
-              <a:rPr lang="en-US" sz="1150" dirty="0" err="1">
-                <a:solidFill>
-                  <a:srgbClr val="8A8070"/>
-                </a:solidFill>
-                <a:latin typeface="Trebuchet MS" pitchFamily="34" charset="0"/>
-                <a:ea typeface="Trebuchet MS" pitchFamily="34" charset="-122"/>
-                <a:cs typeface="Trebuchet MS" pitchFamily="34" charset="-120"/>
-              </a:rPr>
-              <a:t>findElements</a:t>
-            </a:r>
-            <a:r>
-              <a:rPr lang="en-US" sz="1150" dirty="0">
-                <a:solidFill>
-                  <a:srgbClr val="8A8070"/>
-                </a:solidFill>
-                <a:latin typeface="Trebuchet MS" pitchFamily="34" charset="0"/>
-                <a:ea typeface="Trebuchet MS" pitchFamily="34" charset="-122"/>
-                <a:cs typeface="Trebuchet MS" pitchFamily="34" charset="-120"/>
-              </a:rPr>
-              <a:t>().isEmpty(). Then used a JavaScript executor click (jsClick()) to fire the button directly, bypassing Selenium's native click which the opacity overlay was intercepting. Also built a helper that scans all /dp/ product links on the search page and tries each one until it finds a page with the button in the DOM.</a:t>
+              <a:t>Switched from isDisplayed() checks to pure DOM presence, findElements().isEmpty(). Then used a JavaScript executor click (jsClick()) to fire the button directly, bypassing Selenium's native click which the opacity overlay was intercepting. Also built a helper that scans all /dp/ product links on the search page and tries each one until it finds a page with the button in the DOM.</a:t>
             </a:r>
             <a:endParaRPr lang="en-US" sz="1150" dirty="0"/>
           </a:p>

</xml_diff>